<commit_message>
. 	modified:   Idea Compilation/ERD Presentation.pptx
</commit_message>
<xml_diff>
--- a/Idea Compilation/ERD Presentation.pptx
+++ b/Idea Compilation/ERD Presentation.pptx
@@ -332,7 +332,7 @@
             <a:fld id="{1D8BD707-D9CF-40AE-B4C6-C98DA3205C09}" type="datetimeFigureOut">
               <a:rPr lang="en-US" smtClean="0"/>
               <a:pPr/>
-              <a:t>1/17/2026</a:t>
+              <a:t>1/18/2026</a:t>
             </a:fld>
             <a:endParaRPr lang="en-US"/>
           </a:p>
@@ -497,7 +497,7 @@
             <a:fld id="{1D8BD707-D9CF-40AE-B4C6-C98DA3205C09}" type="datetimeFigureOut">
               <a:rPr lang="en-US" smtClean="0"/>
               <a:pPr/>
-              <a:t>1/17/2026</a:t>
+              <a:t>1/18/2026</a:t>
             </a:fld>
             <a:endParaRPr lang="en-US"/>
           </a:p>
@@ -672,7 +672,7 @@
             <a:fld id="{1D8BD707-D9CF-40AE-B4C6-C98DA3205C09}" type="datetimeFigureOut">
               <a:rPr lang="en-US" smtClean="0"/>
               <a:pPr/>
-              <a:t>1/17/2026</a:t>
+              <a:t>1/18/2026</a:t>
             </a:fld>
             <a:endParaRPr lang="en-US"/>
           </a:p>
@@ -837,7 +837,7 @@
             <a:fld id="{1D8BD707-D9CF-40AE-B4C6-C98DA3205C09}" type="datetimeFigureOut">
               <a:rPr lang="en-US" smtClean="0"/>
               <a:pPr/>
-              <a:t>1/17/2026</a:t>
+              <a:t>1/18/2026</a:t>
             </a:fld>
             <a:endParaRPr lang="en-US"/>
           </a:p>
@@ -1079,7 +1079,7 @@
             <a:fld id="{1D8BD707-D9CF-40AE-B4C6-C98DA3205C09}" type="datetimeFigureOut">
               <a:rPr lang="en-US" smtClean="0"/>
               <a:pPr/>
-              <a:t>1/17/2026</a:t>
+              <a:t>1/18/2026</a:t>
             </a:fld>
             <a:endParaRPr lang="en-US"/>
           </a:p>
@@ -1361,7 +1361,7 @@
             <a:fld id="{1D8BD707-D9CF-40AE-B4C6-C98DA3205C09}" type="datetimeFigureOut">
               <a:rPr lang="en-US" smtClean="0"/>
               <a:pPr/>
-              <a:t>1/17/2026</a:t>
+              <a:t>1/18/2026</a:t>
             </a:fld>
             <a:endParaRPr lang="en-US"/>
           </a:p>
@@ -1777,7 +1777,7 @@
             <a:fld id="{1D8BD707-D9CF-40AE-B4C6-C98DA3205C09}" type="datetimeFigureOut">
               <a:rPr lang="en-US" smtClean="0"/>
               <a:pPr/>
-              <a:t>1/17/2026</a:t>
+              <a:t>1/18/2026</a:t>
             </a:fld>
             <a:endParaRPr lang="en-US"/>
           </a:p>
@@ -1891,7 +1891,7 @@
             <a:fld id="{1D8BD707-D9CF-40AE-B4C6-C98DA3205C09}" type="datetimeFigureOut">
               <a:rPr lang="en-US" smtClean="0"/>
               <a:pPr/>
-              <a:t>1/17/2026</a:t>
+              <a:t>1/18/2026</a:t>
             </a:fld>
             <a:endParaRPr lang="en-US"/>
           </a:p>
@@ -1983,7 +1983,7 @@
             <a:fld id="{1D8BD707-D9CF-40AE-B4C6-C98DA3205C09}" type="datetimeFigureOut">
               <a:rPr lang="en-US" smtClean="0"/>
               <a:pPr/>
-              <a:t>1/17/2026</a:t>
+              <a:t>1/18/2026</a:t>
             </a:fld>
             <a:endParaRPr lang="en-US"/>
           </a:p>
@@ -2255,7 +2255,7 @@
             <a:fld id="{1D8BD707-D9CF-40AE-B4C6-C98DA3205C09}" type="datetimeFigureOut">
               <a:rPr lang="en-US" smtClean="0"/>
               <a:pPr/>
-              <a:t>1/17/2026</a:t>
+              <a:t>1/18/2026</a:t>
             </a:fld>
             <a:endParaRPr lang="en-US"/>
           </a:p>
@@ -2504,7 +2504,7 @@
             <a:fld id="{1D8BD707-D9CF-40AE-B4C6-C98DA3205C09}" type="datetimeFigureOut">
               <a:rPr lang="en-US" smtClean="0"/>
               <a:pPr/>
-              <a:t>1/17/2026</a:t>
+              <a:t>1/18/2026</a:t>
             </a:fld>
             <a:endParaRPr lang="en-US"/>
           </a:p>
@@ -2712,7 +2712,7 @@
             <a:fld id="{1D8BD707-D9CF-40AE-B4C6-C98DA3205C09}" type="datetimeFigureOut">
               <a:rPr lang="en-US" smtClean="0"/>
               <a:pPr/>
-              <a:t>1/17/2026</a:t>
+              <a:t>1/18/2026</a:t>
             </a:fld>
             <a:endParaRPr lang="en-US"/>
           </a:p>
@@ -6980,10 +6980,10 @@
       </p:sp>
       <p:pic>
         <p:nvPicPr>
-          <p:cNvPr id="12" name="Picture 11">
+          <p:cNvPr id="13" name="Picture 12">
             <a:extLst>
               <a:ext uri="{FF2B5EF4-FFF2-40B4-BE49-F238E27FC236}">
-                <a16:creationId xmlns:a16="http://schemas.microsoft.com/office/drawing/2014/main" id="{542A3D52-F623-5B21-3D9A-BE3A3AD34B83}"/>
+                <a16:creationId xmlns:a16="http://schemas.microsoft.com/office/drawing/2014/main" id="{54A3A94B-A696-5675-DCBA-8E04ACE6D8FE}"/>
               </a:ext>
             </a:extLst>
           </p:cNvPr>
@@ -7006,8 +7006,8 @@
         </p:blipFill>
         <p:spPr>
           <a:xfrm>
-            <a:off x="1828801" y="2133241"/>
-            <a:ext cx="14630398" cy="7499772"/>
+            <a:off x="1302597" y="1619097"/>
+            <a:ext cx="15682806" cy="8039252"/>
           </a:xfrm>
           <a:prstGeom prst="rect">
             <a:avLst/>

</xml_diff>